<commit_message>
chore: generate technical diagram library artifacts
</commit_message>
<xml_diff>
--- a/templates/presentations/diagrams/Codyssey_Technical_Diagram_Master_Library.pptx
+++ b/templates/presentations/diagrams/Codyssey_Technical_Diagram_Master_Library.pptx
@@ -3489,7 +3489,7 @@
                 <a:ea typeface="Noto Sans CJK KR" pitchFamily="34" charset="-122"/>
                 <a:cs typeface="Noto Sans CJK KR" pitchFamily="34" charset="-120"/>
               </a:rPr>
-              <a:t>B1-1 ~ B7-2 평가 발표 · 학부 프로젝트 · 석박사 연구 · 학회 발표를 위한 편집 가능한 벡터 템플릿</a:t>
+              <a:t>현재 15개 미션 평가 발표 · 학부 프로젝트 · 석박사 연구 · 학회 발표를 위한 편집 가능한 벡터 템플릿</a:t>
             </a:r>
             <a:endParaRPr lang="en-US" sz="1100" dirty="0"/>
           </a:p>
@@ -3924,7 +3924,7 @@
         <p:spPr>
           <a:xfrm>
             <a:off x="658368" y="5989320"/>
-            <a:ext cx="4937760" cy="228600"/>
+            <a:ext cx="5852160" cy="228600"/>
           </a:xfrm>
           <a:prstGeom prst="rect">
             <a:avLst/>
@@ -3948,7 +3948,7 @@
                 <a:ea typeface="Noto Sans CJK KR" pitchFamily="34" charset="-122"/>
                 <a:cs typeface="Noto Sans CJK KR" pitchFamily="34" charset="-120"/>
               </a:rPr>
-              <a:t>v1.0 · 20 reusable layouts · editable PowerPoint vectors</a:t>
+              <a:t>v1.1 · current Mission ID map · 20 reusable layouts · editable PowerPoint vectors</a:t>
             </a:r>
             <a:endParaRPr lang="en-US" sz="860" dirty="0"/>
           </a:p>
@@ -24713,7 +24713,7 @@
                 <a:ea typeface="Noto Sans CJK KR" pitchFamily="34" charset="-122"/>
                 <a:cs typeface="Noto Sans CJK KR" pitchFamily="34" charset="-120"/>
               </a:rPr>
-              <a:t>B1-1 ~ B7-2는 기술 성격에 따라 “주력 다이어그램”이 달라집니다</a:t>
+              <a:t>현재 B1~B7은 기술 성격에 따라 “주력 다이어그램”이 달라집니다</a:t>
             </a:r>
             <a:endParaRPr lang="en-US" sz="2200" dirty="0"/>
           </a:p>
@@ -24754,7 +24754,7 @@
                 <a:ea typeface="Noto Sans CJK KR" pitchFamily="34" charset="-122"/>
                 <a:cs typeface="Noto Sans CJK KR" pitchFamily="34" charset="-120"/>
               </a:rPr>
-              <a:t>같은 템플릿을 반복하지 않고, 미션의 핵심 평가 질문에 맞춰 다이어그램을 선택합니다</a:t>
+              <a:t>Mission ID는 CURRENT-MISSION-MAP 기준 · 미션 주제의 핵심 평가 질문에 맞춰 다이어그램을 선택합니다</a:t>
             </a:r>
             <a:endParaRPr lang="en-US" sz="950" dirty="0"/>
           </a:p>
@@ -25354,7 +25354,7 @@
                 <a:ea typeface="Noto Sans CJK KR" pitchFamily="34" charset="-122"/>
                 <a:cs typeface="Noto Sans CJK KR" pitchFamily="34" charset="-120"/>
               </a:rPr>
-              <a:t>Linux / OS</a:t>
+              <a:t>Web / Front</a:t>
             </a:r>
             <a:endParaRPr lang="en-US" sz="750" dirty="0"/>
           </a:p>
@@ -25436,7 +25436,7 @@
                 <a:ea typeface="Noto Sans CJK KR" pitchFamily="34" charset="-122"/>
                 <a:cs typeface="Noto Sans CJK KR" pitchFamily="34" charset="-120"/>
               </a:rPr>
-              <a:t>Architecture</a:t>
+              <a:t>Event Flow</a:t>
             </a:r>
             <a:endParaRPr lang="en-US" sz="750" dirty="0"/>
           </a:p>
@@ -25518,7 +25518,7 @@
                 <a:ea typeface="Noto Sans CJK KR" pitchFamily="34" charset="-122"/>
                 <a:cs typeface="Noto Sans CJK KR" pitchFamily="34" charset="-120"/>
               </a:rPr>
-              <a:t>Troubleshoot</a:t>
+              <a:t>Before/After</a:t>
             </a:r>
             <a:endParaRPr lang="en-US" sz="750" dirty="0"/>
           </a:p>
@@ -25559,7 +25559,7 @@
                 <a:ea typeface="Noto Sans CJK KR" pitchFamily="34" charset="-122"/>
                 <a:cs typeface="Noto Sans CJK KR" pitchFamily="34" charset="-120"/>
               </a:rPr>
-              <a:t>운영·보안·관제</a:t>
+              <a:t>상호작용·UX</a:t>
             </a:r>
             <a:endParaRPr lang="en-US" sz="750" dirty="0"/>
           </a:p>
@@ -25896,7 +25896,7 @@
                 <a:ea typeface="Noto Sans CJK KR" pitchFamily="34" charset="-122"/>
                 <a:cs typeface="Noto Sans CJK KR" pitchFamily="34" charset="-120"/>
               </a:rPr>
-              <a:t>DS / Algo</a:t>
+              <a:t>Cloud / AI API</a:t>
             </a:r>
             <a:endParaRPr lang="en-US" sz="750" dirty="0"/>
           </a:p>
@@ -25978,7 +25978,7 @@
                 <a:ea typeface="Noto Sans CJK KR" pitchFamily="34" charset="-122"/>
                 <a:cs typeface="Noto Sans CJK KR" pitchFamily="34" charset="-120"/>
               </a:rPr>
-              <a:t>Structure</a:t>
+              <a:t>Network</a:t>
             </a:r>
             <a:endParaRPr lang="en-US" sz="750" dirty="0"/>
           </a:p>
@@ -26019,7 +26019,7 @@
                 <a:ea typeface="Noto Sans CJK KR" pitchFamily="34" charset="-122"/>
                 <a:cs typeface="Noto Sans CJK KR" pitchFamily="34" charset="-120"/>
               </a:rPr>
-              <a:t>Algorithm</a:t>
+              <a:t>Boundary</a:t>
             </a:r>
             <a:endParaRPr lang="en-US" sz="750" dirty="0"/>
           </a:p>
@@ -26060,7 +26060,7 @@
                 <a:ea typeface="Noto Sans CJK KR" pitchFamily="34" charset="-122"/>
                 <a:cs typeface="Noto Sans CJK KR" pitchFamily="34" charset="-120"/>
               </a:rPr>
-              <a:t>Complexity</a:t>
+              <a:t>Pipeline</a:t>
             </a:r>
             <a:endParaRPr lang="en-US" sz="750" dirty="0"/>
           </a:p>
@@ -26101,7 +26101,7 @@
                 <a:ea typeface="Noto Sans CJK KR" pitchFamily="34" charset="-122"/>
                 <a:cs typeface="Noto Sans CJK KR" pitchFamily="34" charset="-120"/>
               </a:rPr>
-              <a:t>연산·불변조건</a:t>
+              <a:t>배포·권한·실패</a:t>
             </a:r>
             <a:endParaRPr lang="en-US" sz="750" dirty="0"/>
           </a:p>
@@ -26167,7 +26167,7 @@
                 <a:ea typeface="Noto Sans CJK KR" pitchFamily="34" charset="-122"/>
                 <a:cs typeface="Noto Sans CJK KR" pitchFamily="34" charset="-120"/>
               </a:rPr>
-              <a:t>Web / Front</a:t>
+              <a:t>Linux / OS</a:t>
             </a:r>
             <a:endParaRPr lang="en-US" sz="750" dirty="0"/>
           </a:p>
@@ -26249,7 +26249,7 @@
                 <a:ea typeface="Noto Sans CJK KR" pitchFamily="34" charset="-122"/>
                 <a:cs typeface="Noto Sans CJK KR" pitchFamily="34" charset="-120"/>
               </a:rPr>
-              <a:t>Event Flow</a:t>
+              <a:t>Architecture</a:t>
             </a:r>
             <a:endParaRPr lang="en-US" sz="750" dirty="0"/>
           </a:p>
@@ -26331,7 +26331,7 @@
                 <a:ea typeface="Noto Sans CJK KR" pitchFamily="34" charset="-122"/>
                 <a:cs typeface="Noto Sans CJK KR" pitchFamily="34" charset="-120"/>
               </a:rPr>
-              <a:t>Before/After</a:t>
+              <a:t>Troubleshoot</a:t>
             </a:r>
             <a:endParaRPr lang="en-US" sz="750" dirty="0"/>
           </a:p>
@@ -26372,7 +26372,7 @@
                 <a:ea typeface="Noto Sans CJK KR" pitchFamily="34" charset="-122"/>
                 <a:cs typeface="Noto Sans CJK KR" pitchFamily="34" charset="-120"/>
               </a:rPr>
-              <a:t>상호작용·UX</a:t>
+              <a:t>운영·보안·관제</a:t>
             </a:r>
             <a:endParaRPr lang="en-US" sz="750" dirty="0"/>
           </a:p>
@@ -26438,7 +26438,7 @@
                 <a:ea typeface="Noto Sans CJK KR" pitchFamily="34" charset="-122"/>
                 <a:cs typeface="Noto Sans CJK KR" pitchFamily="34" charset="-120"/>
               </a:rPr>
-              <a:t>DB / Backend</a:t>
+              <a:t>DS / Algo</a:t>
             </a:r>
             <a:endParaRPr lang="en-US" sz="750" dirty="0"/>
           </a:p>
@@ -26520,7 +26520,7 @@
                 <a:ea typeface="Noto Sans CJK KR" pitchFamily="34" charset="-122"/>
                 <a:cs typeface="Noto Sans CJK KR" pitchFamily="34" charset="-120"/>
               </a:rPr>
-              <a:t>ERD</a:t>
+              <a:t>Structure</a:t>
             </a:r>
             <a:endParaRPr lang="en-US" sz="750" dirty="0"/>
           </a:p>
@@ -26561,7 +26561,7 @@
                 <a:ea typeface="Noto Sans CJK KR" pitchFamily="34" charset="-122"/>
                 <a:cs typeface="Noto Sans CJK KR" pitchFamily="34" charset="-120"/>
               </a:rPr>
-              <a:t>Sequence</a:t>
+              <a:t>Algorithm</a:t>
             </a:r>
             <a:endParaRPr lang="en-US" sz="750" dirty="0"/>
           </a:p>
@@ -26602,7 +26602,7 @@
                 <a:ea typeface="Noto Sans CJK KR" pitchFamily="34" charset="-122"/>
                 <a:cs typeface="Noto Sans CJK KR" pitchFamily="34" charset="-120"/>
               </a:rPr>
-              <a:t>Trust</a:t>
+              <a:t>Complexity</a:t>
             </a:r>
             <a:endParaRPr lang="en-US" sz="750" dirty="0"/>
           </a:p>
@@ -26643,7 +26643,7 @@
                 <a:ea typeface="Noto Sans CJK KR" pitchFamily="34" charset="-122"/>
                 <a:cs typeface="Noto Sans CJK KR" pitchFamily="34" charset="-120"/>
               </a:rPr>
-              <a:t>관계·API·인가</a:t>
+              <a:t>연산·불변조건</a:t>
             </a:r>
             <a:endParaRPr lang="en-US" sz="750" dirty="0"/>
           </a:p>
@@ -26709,7 +26709,7 @@
                 <a:ea typeface="Noto Sans CJK KR" pitchFamily="34" charset="-122"/>
                 <a:cs typeface="Noto Sans CJK KR" pitchFamily="34" charset="-120"/>
               </a:rPr>
-              <a:t>Cloud / AI API</a:t>
+              <a:t>DB / Backend</a:t>
             </a:r>
             <a:endParaRPr lang="en-US" sz="750" dirty="0"/>
           </a:p>
@@ -26791,7 +26791,7 @@
                 <a:ea typeface="Noto Sans CJK KR" pitchFamily="34" charset="-122"/>
                 <a:cs typeface="Noto Sans CJK KR" pitchFamily="34" charset="-120"/>
               </a:rPr>
-              <a:t>Network</a:t>
+              <a:t>ERD</a:t>
             </a:r>
             <a:endParaRPr lang="en-US" sz="750" dirty="0"/>
           </a:p>
@@ -26832,7 +26832,7 @@
                 <a:ea typeface="Noto Sans CJK KR" pitchFamily="34" charset="-122"/>
                 <a:cs typeface="Noto Sans CJK KR" pitchFamily="34" charset="-120"/>
               </a:rPr>
-              <a:t>Boundary</a:t>
+              <a:t>Sequence</a:t>
             </a:r>
             <a:endParaRPr lang="en-US" sz="750" dirty="0"/>
           </a:p>
@@ -26873,7 +26873,7 @@
                 <a:ea typeface="Noto Sans CJK KR" pitchFamily="34" charset="-122"/>
                 <a:cs typeface="Noto Sans CJK KR" pitchFamily="34" charset="-120"/>
               </a:rPr>
-              <a:t>Pipeline</a:t>
+              <a:t>Trust</a:t>
             </a:r>
             <a:endParaRPr lang="en-US" sz="750" dirty="0"/>
           </a:p>
@@ -26914,7 +26914,7 @@
                 <a:ea typeface="Noto Sans CJK KR" pitchFamily="34" charset="-122"/>
                 <a:cs typeface="Noto Sans CJK KR" pitchFamily="34" charset="-120"/>
               </a:rPr>
-              <a:t>배포·권한·실패</a:t>
+              <a:t>관계·API·인가</a:t>
             </a:r>
             <a:endParaRPr lang="en-US" sz="750" dirty="0"/>
           </a:p>
@@ -27408,7 +27408,7 @@
                 <a:ea typeface="Noto Sans CJK KR" pitchFamily="34" charset="-122"/>
                 <a:cs typeface="Noto Sans CJK KR" pitchFamily="34" charset="-120"/>
               </a:rPr>
-              <a:t>B5·B6·B7의 기본형 · 단순 나열보다 계층과 책임을 먼저 드러냅니다</a:t>
+              <a:t>B3·B6·B7의 기본형 · 단순 나열보다 계층과 책임을 먼저 드러냅니다</a:t>
             </a:r>
             <a:endParaRPr lang="en-US" sz="950" dirty="0"/>
           </a:p>

</xml_diff>